<commit_message>
Trames : correction des identifiants de formes (fichier réparé par PowerPoint)
Co-Authored-By: Claude Sonnet 5.5 <noreply@anthropic.com>
Claude-Session: https://claude.ai/code/session_01XPwnZBmWUGhvYebrP3X3Z2
</commit_message>
<xml_diff>
--- a/trames_presentation/Trame_Enedril_paysage_A4.pptx
+++ b/trames_presentation/Trame_Enedril_paysage_A4.pptx
@@ -136,7 +136,7 @@
       </p:grpSpPr>
       <p:sp>
         <p:nvSpPr>
-          <p:cNvPr id="1" name="Titre"/>
+          <p:cNvPr id="2" name="Titre"/>
           <p:cNvSpPr>
             <a:spLocks noGrp="1"/>
           </p:cNvSpPr>
@@ -178,7 +178,7 @@
       </p:sp>
       <p:sp>
         <p:nvSpPr>
-          <p:cNvPr id="2" name="Sous-titre"/>
+          <p:cNvPr id="3" name="Sous-titre"/>
           <p:cNvSpPr>
             <a:spLocks noGrp="1"/>
           </p:cNvSpPr>
@@ -232,7 +232,7 @@
 </file>
 
 <file path=ppt/slideLayouts/slideLayout2.xml><?xml version="1.0" encoding="utf-8"?>
-<p:sldLayout xmlns:a="http://schemas.openxmlformats.org/drawingml/2006/main" xmlns:r="http://schemas.openxmlformats.org/officeDocument/2006/relationships" xmlns:p="http://schemas.openxmlformats.org/presentationml/2006/main" type="obj" preserve="1">
+<p:sldLayout xmlns:a="http://schemas.openxmlformats.org/drawingml/2006/main" xmlns:r="http://schemas.openxmlformats.org/officeDocument/2006/relationships" xmlns:p="http://schemas.openxmlformats.org/presentationml/2006/main" type="secHead" preserve="1">
   <p:cSld name="Titre de section">
     <p:bg>
       <p:bgPr>
@@ -262,7 +262,7 @@
       </p:grpSpPr>
       <p:sp>
         <p:nvSpPr>
-          <p:cNvPr id="1" name="Titre"/>
+          <p:cNvPr id="2" name="Titre"/>
           <p:cNvSpPr>
             <a:spLocks noGrp="1"/>
           </p:cNvSpPr>
@@ -304,7 +304,7 @@
       </p:sp>
       <p:sp>
         <p:nvSpPr>
-          <p:cNvPr id="2" name="Texte"/>
+          <p:cNvPr id="3" name="Texte"/>
           <p:cNvSpPr>
             <a:spLocks noGrp="1"/>
           </p:cNvSpPr>
@@ -358,7 +358,7 @@
 </file>
 
 <file path=ppt/slideLayouts/slideLayout3.xml><?xml version="1.0" encoding="utf-8"?>
-<p:sldLayout xmlns:a="http://schemas.openxmlformats.org/drawingml/2006/main" xmlns:r="http://schemas.openxmlformats.org/officeDocument/2006/relationships" xmlns:p="http://schemas.openxmlformats.org/presentationml/2006/main" type="secHead" preserve="1">
+<p:sldLayout xmlns:a="http://schemas.openxmlformats.org/drawingml/2006/main" xmlns:r="http://schemas.openxmlformats.org/officeDocument/2006/relationships" xmlns:p="http://schemas.openxmlformats.org/presentationml/2006/main" type="obj" preserve="1">
   <p:cSld name="Titre et contenu">
     <p:bg>
       <p:bgPr>
@@ -388,7 +388,7 @@
       </p:grpSpPr>
       <p:sp>
         <p:nvSpPr>
-          <p:cNvPr id="1" name="Titre"/>
+          <p:cNvPr id="2" name="Titre"/>
           <p:cNvSpPr>
             <a:spLocks noGrp="1"/>
           </p:cNvSpPr>
@@ -430,7 +430,7 @@
       </p:sp>
       <p:sp>
         <p:nvSpPr>
-          <p:cNvPr id="2" name="Contenu"/>
+          <p:cNvPr id="3" name="Contenu"/>
           <p:cNvSpPr>
             <a:spLocks noGrp="1"/>
           </p:cNvSpPr>
@@ -562,7 +562,7 @@
       </p:grpSpPr>
       <p:sp>
         <p:nvSpPr>
-          <p:cNvPr id="1" name="Titre"/>
+          <p:cNvPr id="2" name="Titre"/>
           <p:cNvSpPr>
             <a:spLocks noGrp="1"/>
           </p:cNvSpPr>
@@ -604,7 +604,7 @@
       </p:sp>
       <p:sp>
         <p:nvSpPr>
-          <p:cNvPr id="2" name="Colonne 1"/>
+          <p:cNvPr id="3" name="Colonne 1"/>
           <p:cNvSpPr>
             <a:spLocks noGrp="1"/>
           </p:cNvSpPr>
@@ -694,7 +694,7 @@
       </p:sp>
       <p:sp>
         <p:nvSpPr>
-          <p:cNvPr id="3" name="Colonne 2"/>
+          <p:cNvPr id="4" name="Colonne 2"/>
           <p:cNvSpPr>
             <a:spLocks noGrp="1"/>
           </p:cNvSpPr>
@@ -796,7 +796,7 @@
 </file>
 
 <file path=ppt/slideLayouts/slideLayout5.xml><?xml version="1.0" encoding="utf-8"?>
-<p:sldLayout xmlns:a="http://schemas.openxmlformats.org/drawingml/2006/main" xmlns:r="http://schemas.openxmlformats.org/officeDocument/2006/relationships" xmlns:p="http://schemas.openxmlformats.org/presentationml/2006/main" type="twoTxTwoObj" preserve="1">
+<p:sldLayout xmlns:a="http://schemas.openxmlformats.org/drawingml/2006/main" xmlns:r="http://schemas.openxmlformats.org/officeDocument/2006/relationships" xmlns:p="http://schemas.openxmlformats.org/presentationml/2006/main" type="obj" preserve="1">
   <p:cSld name="Chiffres clés">
     <p:bg>
       <p:bgPr>
@@ -826,7 +826,7 @@
       </p:grpSpPr>
       <p:sp>
         <p:nvSpPr>
-          <p:cNvPr id="1" name="Titre"/>
+          <p:cNvPr id="2" name="Titre"/>
           <p:cNvSpPr>
             <a:spLocks noGrp="1"/>
           </p:cNvSpPr>
@@ -868,7 +868,7 @@
       </p:sp>
       <p:sp>
         <p:nvSpPr>
-          <p:cNvPr id="2" name="Chiffre 1"/>
+          <p:cNvPr id="3" name="Chiffre 1"/>
           <p:cNvSpPr>
             <a:spLocks noGrp="1"/>
           </p:cNvSpPr>
@@ -919,7 +919,7 @@
       </p:sp>
       <p:sp>
         <p:nvSpPr>
-          <p:cNvPr id="3" name="Chiffre 2"/>
+          <p:cNvPr id="4" name="Chiffre 2"/>
           <p:cNvSpPr>
             <a:spLocks noGrp="1"/>
           </p:cNvSpPr>
@@ -970,7 +970,7 @@
       </p:sp>
       <p:sp>
         <p:nvSpPr>
-          <p:cNvPr id="4" name="Chiffre 3"/>
+          <p:cNvPr id="5" name="Chiffre 3"/>
           <p:cNvSpPr>
             <a:spLocks noGrp="1"/>
           </p:cNvSpPr>
@@ -1021,7 +1021,7 @@
       </p:sp>
       <p:sp>
         <p:nvSpPr>
-          <p:cNvPr id="5" name="Chiffre 4"/>
+          <p:cNvPr id="6" name="Chiffre 4"/>
           <p:cNvSpPr>
             <a:spLocks noGrp="1"/>
           </p:cNvSpPr>
@@ -1072,7 +1072,7 @@
       </p:sp>
       <p:sp>
         <p:nvSpPr>
-          <p:cNvPr id="6" name="Contenu"/>
+          <p:cNvPr id="7" name="Contenu"/>
           <p:cNvSpPr>
             <a:spLocks noGrp="1"/>
           </p:cNvSpPr>
@@ -1204,7 +1204,7 @@
       </p:grpSpPr>
       <p:sp>
         <p:nvSpPr>
-          <p:cNvPr id="1" name="Titre"/>
+          <p:cNvPr id="2" name="Titre"/>
           <p:cNvSpPr>
             <a:spLocks noGrp="1"/>
           </p:cNvSpPr>
@@ -1258,7 +1258,7 @@
 </file>
 
 <file path=ppt/slideLayouts/slideLayout7.xml><?xml version="1.0" encoding="utf-8"?>
-<p:sldLayout xmlns:a="http://schemas.openxmlformats.org/drawingml/2006/main" xmlns:r="http://schemas.openxmlformats.org/officeDocument/2006/relationships" xmlns:p="http://schemas.openxmlformats.org/presentationml/2006/main" type="blank" preserve="1">
+<p:sldLayout xmlns:a="http://schemas.openxmlformats.org/drawingml/2006/main" xmlns:r="http://schemas.openxmlformats.org/officeDocument/2006/relationships" xmlns:p="http://schemas.openxmlformats.org/presentationml/2006/main" type="titleOnly" preserve="1">
   <p:cSld name="Fin et contacts">
     <p:bg>
       <p:bgPr>
@@ -1288,7 +1288,7 @@
       </p:grpSpPr>
       <p:sp>
         <p:nvSpPr>
-          <p:cNvPr id="1" name="Titre"/>
+          <p:cNvPr id="2" name="Titre"/>
           <p:cNvSpPr>
             <a:spLocks noGrp="1"/>
           </p:cNvSpPr>

</xml_diff>

<commit_message>
Trames : couleur de puce invalide corrigée (cause de la réparation PowerPoint)
Co-Authored-By: Claude Sonnet 5.5 <noreply@anthropic.com>
Claude-Session: https://claude.ai/code/session_01XPwnZBmWUGhvYebrP3X3Z2
</commit_message>
<xml_diff>
--- a/trames_presentation/Trame_Enedril_paysage_A4.pptx
+++ b/trames_presentation/Trame_Enedril_paysage_A4.pptx
@@ -449,24 +449,12 @@
             <a:normAutofit/>
           </a:bodyPr>
           <a:lstStyle>
-            <a:lvl1pPr marL="0" indent="0" algn="l">
-              <a:spcBef>
-                <a:spcPts val="0"/>
-              </a:spcBef>
-              <a:buNone/>
-              <a:defRPr sz="1300" b="0">
-                <a:solidFill>
-                  <a:srgbClr val="0B1B2E"/>
-                </a:solidFill>
-                <a:latin typeface="Ubuntu Mono"/>
-              </a:defRPr>
-            </a:lvl1pPr>
-            <a:lvl1pPr marL="177800" indent="-177800">
+            <a:lvl1pPr marL="177800" indent="-177800" algn="l">
               <a:spcBef>
                 <a:spcPts val="600"/>
               </a:spcBef>
               <a:buClr>
-                <a:srgbClr val="#1CB2FE"/>
+                <a:srgbClr val="1CB2FE"/>
               </a:buClr>
               <a:buFont typeface="Wingdings"/>
               <a:buChar char="§"/>
@@ -477,12 +465,12 @@
                 <a:latin typeface="Ubuntu Mono"/>
               </a:defRPr>
             </a:lvl1pPr>
-            <a:lvl2pPr marL="381000" indent="-177800">
+            <a:lvl2pPr marL="381000" indent="-177800" algn="l">
               <a:spcBef>
                 <a:spcPts val="600"/>
               </a:spcBef>
               <a:buClr>
-                <a:srgbClr val="#1CB2FE"/>
+                <a:srgbClr val="1CB2FE"/>
               </a:buClr>
               <a:buFont typeface="Wingdings"/>
               <a:buChar char="§"/>
@@ -493,12 +481,12 @@
                 <a:latin typeface="Ubuntu Mono"/>
               </a:defRPr>
             </a:lvl2pPr>
-            <a:lvl3pPr marL="584200" indent="-177800">
+            <a:lvl3pPr marL="584200" indent="-177800" algn="l">
               <a:spcBef>
                 <a:spcPts val="600"/>
               </a:spcBef>
               <a:buClr>
-                <a:srgbClr val="#1CB2FE"/>
+                <a:srgbClr val="1CB2FE"/>
               </a:buClr>
               <a:buFont typeface="Wingdings"/>
               <a:buChar char="§"/>
@@ -623,24 +611,12 @@
             <a:normAutofit/>
           </a:bodyPr>
           <a:lstStyle>
-            <a:lvl1pPr marL="0" indent="0" algn="l">
-              <a:spcBef>
-                <a:spcPts val="0"/>
-              </a:spcBef>
-              <a:buNone/>
-              <a:defRPr sz="1250" b="0">
-                <a:solidFill>
-                  <a:srgbClr val="0B1B2E"/>
-                </a:solidFill>
-                <a:latin typeface="Ubuntu Mono"/>
-              </a:defRPr>
-            </a:lvl1pPr>
-            <a:lvl1pPr marL="177800" indent="-177800">
+            <a:lvl1pPr marL="177800" indent="-177800" algn="l">
               <a:spcBef>
                 <a:spcPts val="600"/>
               </a:spcBef>
               <a:buClr>
-                <a:srgbClr val="#1CB2FE"/>
+                <a:srgbClr val="1CB2FE"/>
               </a:buClr>
               <a:buFont typeface="Wingdings"/>
               <a:buChar char="§"/>
@@ -651,12 +627,12 @@
                 <a:latin typeface="Ubuntu Mono"/>
               </a:defRPr>
             </a:lvl1pPr>
-            <a:lvl2pPr marL="381000" indent="-177800">
+            <a:lvl2pPr marL="381000" indent="-177800" algn="l">
               <a:spcBef>
                 <a:spcPts val="600"/>
               </a:spcBef>
               <a:buClr>
-                <a:srgbClr val="#1CB2FE"/>
+                <a:srgbClr val="1CB2FE"/>
               </a:buClr>
               <a:buFont typeface="Wingdings"/>
               <a:buChar char="§"/>
@@ -667,12 +643,12 @@
                 <a:latin typeface="Ubuntu Mono"/>
               </a:defRPr>
             </a:lvl2pPr>
-            <a:lvl3pPr marL="584200" indent="-177800">
+            <a:lvl3pPr marL="584200" indent="-177800" algn="l">
               <a:spcBef>
                 <a:spcPts val="600"/>
               </a:spcBef>
               <a:buClr>
-                <a:srgbClr val="#1CB2FE"/>
+                <a:srgbClr val="1CB2FE"/>
               </a:buClr>
               <a:buFont typeface="Wingdings"/>
               <a:buChar char="§"/>
@@ -713,24 +689,12 @@
             <a:normAutofit/>
           </a:bodyPr>
           <a:lstStyle>
-            <a:lvl1pPr marL="0" indent="0" algn="l">
-              <a:spcBef>
-                <a:spcPts val="0"/>
-              </a:spcBef>
-              <a:buNone/>
-              <a:defRPr sz="1250" b="0">
-                <a:solidFill>
-                  <a:srgbClr val="0B1B2E"/>
-                </a:solidFill>
-                <a:latin typeface="Ubuntu Mono"/>
-              </a:defRPr>
-            </a:lvl1pPr>
-            <a:lvl1pPr marL="177800" indent="-177800">
+            <a:lvl1pPr marL="177800" indent="-177800" algn="l">
               <a:spcBef>
                 <a:spcPts val="600"/>
               </a:spcBef>
               <a:buClr>
-                <a:srgbClr val="#1CB2FE"/>
+                <a:srgbClr val="1CB2FE"/>
               </a:buClr>
               <a:buFont typeface="Wingdings"/>
               <a:buChar char="§"/>
@@ -741,12 +705,12 @@
                 <a:latin typeface="Ubuntu Mono"/>
               </a:defRPr>
             </a:lvl1pPr>
-            <a:lvl2pPr marL="381000" indent="-177800">
+            <a:lvl2pPr marL="381000" indent="-177800" algn="l">
               <a:spcBef>
                 <a:spcPts val="600"/>
               </a:spcBef>
               <a:buClr>
-                <a:srgbClr val="#1CB2FE"/>
+                <a:srgbClr val="1CB2FE"/>
               </a:buClr>
               <a:buFont typeface="Wingdings"/>
               <a:buChar char="§"/>
@@ -757,12 +721,12 @@
                 <a:latin typeface="Ubuntu Mono"/>
               </a:defRPr>
             </a:lvl2pPr>
-            <a:lvl3pPr marL="584200" indent="-177800">
+            <a:lvl3pPr marL="584200" indent="-177800" algn="l">
               <a:spcBef>
                 <a:spcPts val="600"/>
               </a:spcBef>
               <a:buClr>
-                <a:srgbClr val="#1CB2FE"/>
+                <a:srgbClr val="1CB2FE"/>
               </a:buClr>
               <a:buFont typeface="Wingdings"/>
               <a:buChar char="§"/>
@@ -1091,24 +1055,12 @@
             <a:normAutofit/>
           </a:bodyPr>
           <a:lstStyle>
-            <a:lvl1pPr marL="0" indent="0" algn="l">
-              <a:spcBef>
-                <a:spcPts val="0"/>
-              </a:spcBef>
-              <a:buNone/>
-              <a:defRPr sz="1250" b="0">
-                <a:solidFill>
-                  <a:srgbClr val="0B1B2E"/>
-                </a:solidFill>
-                <a:latin typeface="Ubuntu Mono"/>
-              </a:defRPr>
-            </a:lvl1pPr>
-            <a:lvl1pPr marL="177800" indent="-177800">
+            <a:lvl1pPr marL="177800" indent="-177800" algn="l">
               <a:spcBef>
                 <a:spcPts val="600"/>
               </a:spcBef>
               <a:buClr>
-                <a:srgbClr val="#1CB2FE"/>
+                <a:srgbClr val="1CB2FE"/>
               </a:buClr>
               <a:buFont typeface="Wingdings"/>
               <a:buChar char="§"/>
@@ -1119,12 +1071,12 @@
                 <a:latin typeface="Ubuntu Mono"/>
               </a:defRPr>
             </a:lvl1pPr>
-            <a:lvl2pPr marL="381000" indent="-177800">
+            <a:lvl2pPr marL="381000" indent="-177800" algn="l">
               <a:spcBef>
                 <a:spcPts val="600"/>
               </a:spcBef>
               <a:buClr>
-                <a:srgbClr val="#1CB2FE"/>
+                <a:srgbClr val="1CB2FE"/>
               </a:buClr>
               <a:buFont typeface="Wingdings"/>
               <a:buChar char="§"/>
@@ -1135,12 +1087,12 @@
                 <a:latin typeface="Ubuntu Mono"/>
               </a:defRPr>
             </a:lvl2pPr>
-            <a:lvl3pPr marL="584200" indent="-177800">
+            <a:lvl3pPr marL="584200" indent="-177800" algn="l">
               <a:spcBef>
                 <a:spcPts val="600"/>
               </a:spcBef>
               <a:buClr>
-                <a:srgbClr val="#1CB2FE"/>
+                <a:srgbClr val="1CB2FE"/>
               </a:buClr>
               <a:buFont typeface="Wingdings"/>
               <a:buChar char="§"/>

</xml_diff>